<commit_message>
lectures and proj 3
</commit_message>
<xml_diff>
--- a/lectures/Lecture_18_Community_assembly_IV.pptx
+++ b/lectures/Lecture_18_Community_assembly_IV.pptx
@@ -891,7 +891,7 @@
   <p:cSld>
     <p:spTree>
       <p:nvGrpSpPr>
-        <p:cNvPr id="61" name="Shape 61"/>
+        <p:cNvPr id="62" name="Shape 62"/>
         <p:cNvGrpSpPr/>
         <p:nvPr/>
       </p:nvGrpSpPr>
@@ -905,7 +905,7 @@
       </p:grpSpPr>
       <p:sp>
         <p:nvSpPr>
-          <p:cNvPr id="62" name="Google Shape;62;g2d8981be037_0_58:notes"/>
+          <p:cNvPr id="63" name="Google Shape;63;g2d8981be037_0_58:notes"/>
           <p:cNvSpPr/>
           <p:nvPr>
             <p:ph idx="2" type="sldImg"/>
@@ -940,7 +940,7 @@
       </p:sp>
       <p:sp>
         <p:nvSpPr>
-          <p:cNvPr id="63" name="Google Shape;63;g2d8981be037_0_58:notes"/>
+          <p:cNvPr id="64" name="Google Shape;64;g2d8981be037_0_58:notes"/>
           <p:cNvSpPr txBox="1"/>
           <p:nvPr>
             <p:ph idx="1" type="body"/>
@@ -5843,6 +5843,86 @@
             </a:r>
             <a:endParaRPr/>
           </a:p>
+          <a:p>
+            <a:pPr indent="0" lvl="0" marL="0" rtl="0" algn="l">
+              <a:spcBef>
+                <a:spcPts val="0"/>
+              </a:spcBef>
+              <a:spcAft>
+                <a:spcPts val="0"/>
+              </a:spcAft>
+              <a:buNone/>
+            </a:pPr>
+            <a:r>
+              <a:t/>
+            </a:r>
+            <a:endParaRPr/>
+          </a:p>
+          <a:p>
+            <a:pPr indent="0" lvl="0" marL="0" rtl="0" algn="l">
+              <a:spcBef>
+                <a:spcPts val="0"/>
+              </a:spcBef>
+              <a:spcAft>
+                <a:spcPts val="0"/>
+              </a:spcAft>
+              <a:buNone/>
+            </a:pPr>
+            <a:r>
+              <a:t/>
+            </a:r>
+            <a:endParaRPr/>
+          </a:p>
+        </p:txBody>
+      </p:sp>
+      <p:sp>
+        <p:nvSpPr>
+          <p:cNvPr id="61" name="Google Shape;61;p14"/>
+          <p:cNvSpPr txBox="1"/>
+          <p:nvPr/>
+        </p:nvSpPr>
+        <p:spPr>
+          <a:xfrm>
+            <a:off x="1329975" y="1817575"/>
+            <a:ext cx="5708400" cy="461700"/>
+          </a:xfrm>
+          <a:prstGeom prst="rect">
+            <a:avLst/>
+          </a:prstGeom>
+          <a:noFill/>
+          <a:ln>
+            <a:noFill/>
+          </a:ln>
+        </p:spPr>
+        <p:txBody>
+          <a:bodyPr anchorCtr="0" anchor="t" bIns="91425" lIns="91425" spcFirstLastPara="1" rIns="91425" wrap="square" tIns="91425">
+            <a:spAutoFit/>
+          </a:bodyPr>
+          <a:lstStyle/>
+          <a:p>
+            <a:pPr indent="0" lvl="0" marL="0" rtl="0" algn="l">
+              <a:spcBef>
+                <a:spcPts val="0"/>
+              </a:spcBef>
+              <a:spcAft>
+                <a:spcPts val="0"/>
+              </a:spcAft>
+              <a:buNone/>
+            </a:pPr>
+            <a:r>
+              <a:rPr lang="en" sz="1800">
+                <a:solidFill>
+                  <a:schemeClr val="dk2"/>
+                </a:solidFill>
+              </a:rPr>
+              <a:t>Student slides</a:t>
+            </a:r>
+            <a:endParaRPr sz="1800">
+              <a:solidFill>
+                <a:schemeClr val="dk2"/>
+              </a:solidFill>
+            </a:endParaRPr>
+          </a:p>
         </p:txBody>
       </p:sp>
     </p:spTree>
@@ -5858,7 +5938,7 @@
   <p:cSld>
     <p:spTree>
       <p:nvGrpSpPr>
-        <p:cNvPr id="64" name="Shape 64"/>
+        <p:cNvPr id="65" name="Shape 65"/>
         <p:cNvGrpSpPr/>
         <p:nvPr/>
       </p:nvGrpSpPr>
@@ -5872,7 +5952,7 @@
       </p:grpSpPr>
       <p:sp>
         <p:nvSpPr>
-          <p:cNvPr id="65" name="Google Shape;65;p15"/>
+          <p:cNvPr id="66" name="Google Shape;66;p15"/>
           <p:cNvSpPr txBox="1"/>
           <p:nvPr>
             <p:ph type="title"/>

</xml_diff>